<commit_message>
Unit 2 slide 4: audit-report footnote
Jorge added "*The obligation to audit has its own thresholds, which are
lower." to the abbreviated-accounts table in 02.pptx. Refreshed
source-pptx/02.pptx and re-extracted; confirmed by diff that this is the
only change in the whole deck.

The footnote textbox extracts as an aside, which renders as the
dashed-border speaker-cue pill - wrong look for student-facing content.
Used overrides.json instead: unit2."4" hides the aside and sets it as the
slide's caption, so it renders as a plain line under the table like any
other caption.

Co-Authored-By: Claude Sonnet 5 <noreply@anthropic.com>
</commit_message>
<xml_diff>
--- a/source-pptx/02.pptx
+++ b/source-pptx/02.pptx
@@ -144,932 +144,45 @@
 </p:presentation>
 </file>
 
+<file path=ppt/revisionInfo.xml><?xml version="1.0" encoding="utf-8"?>
+<p1510:revInfo xmlns:a="http://schemas.openxmlformats.org/drawingml/2006/main" xmlns:r="http://schemas.openxmlformats.org/officeDocument/2006/relationships" xmlns:p1510="http://schemas.microsoft.com/office/powerpoint/2015/10/main">
+  <p1510:revLst>
+    <p1510:client id="{180601C7-325F-4628-9089-8AB94C564515}" v="2" dt="2026-09-11T08:30:38.073"/>
+  </p1510:revLst>
+</p1510:revInfo>
+</file>
+
 <file path=ppt/changesInfos/changesInfo1.xml><?xml version="1.0" encoding="utf-8"?>
 <pc:chgInfo xmlns:a="http://schemas.openxmlformats.org/drawingml/2006/main" xmlns:r="http://schemas.openxmlformats.org/officeDocument/2006/relationships" xmlns:ac="http://schemas.microsoft.com/office/drawing/2013/main/command" xmlns:pc="http://schemas.microsoft.com/office/powerpoint/2013/main/command">
   <pc:docChgLst>
     <pc:chgData name="JORGE GALLUD CANO" userId="aa07a950-3061-465d-9845-1f16ea714d1e" providerId="ADAL" clId="{652E886E-EB52-40C6-999B-D6033CDA24D2}"/>
     <pc:docChg chg="undo custSel addSld modSld sldOrd">
-      <pc:chgData name="JORGE GALLUD CANO" userId="aa07a950-3061-465d-9845-1f16ea714d1e" providerId="ADAL" clId="{652E886E-EB52-40C6-999B-D6033CDA24D2}" dt="2025-10-16T08:52:52.676" v="1132" actId="15"/>
+      <pc:chgData name="JORGE GALLUD CANO" userId="aa07a950-3061-465d-9845-1f16ea714d1e" providerId="ADAL" clId="{652E886E-EB52-40C6-999B-D6033CDA24D2}" dt="2026-09-11T08:30:56.715" v="1156" actId="404"/>
       <pc:docMkLst>
         <pc:docMk/>
       </pc:docMkLst>
-      <pc:sldChg chg="modSp mod">
-        <pc:chgData name="JORGE GALLUD CANO" userId="aa07a950-3061-465d-9845-1f16ea714d1e" providerId="ADAL" clId="{652E886E-EB52-40C6-999B-D6033CDA24D2}" dt="2025-09-15T08:44:13.519" v="93" actId="20577"/>
-        <pc:sldMkLst>
-          <pc:docMk/>
-          <pc:sldMk cId="579264008" sldId="263"/>
-        </pc:sldMkLst>
-      </pc:sldChg>
-      <pc:sldChg chg="modSp mod modNotesTx">
-        <pc:chgData name="JORGE GALLUD CANO" userId="aa07a950-3061-465d-9845-1f16ea714d1e" providerId="ADAL" clId="{652E886E-EB52-40C6-999B-D6033CDA24D2}" dt="2025-09-15T08:48:06.843" v="211" actId="6549"/>
-        <pc:sldMkLst>
-          <pc:docMk/>
-          <pc:sldMk cId="1005136347" sldId="287"/>
-        </pc:sldMkLst>
-      </pc:sldChg>
-      <pc:sldChg chg="modSp mod">
-        <pc:chgData name="JORGE GALLUD CANO" userId="aa07a950-3061-465d-9845-1f16ea714d1e" providerId="ADAL" clId="{652E886E-EB52-40C6-999B-D6033CDA24D2}" dt="2025-09-15T08:42:11.445" v="73" actId="20577"/>
-        <pc:sldMkLst>
-          <pc:docMk/>
-          <pc:sldMk cId="4031023037" sldId="514"/>
-        </pc:sldMkLst>
-      </pc:sldChg>
-      <pc:sldChg chg="modSp">
-        <pc:chgData name="JORGE GALLUD CANO" userId="aa07a950-3061-465d-9845-1f16ea714d1e" providerId="ADAL" clId="{652E886E-EB52-40C6-999B-D6033CDA24D2}" dt="2025-09-11T08:44:22.789" v="0"/>
+      <pc:sldChg chg="addSp modSp mod">
+        <pc:chgData name="JORGE GALLUD CANO" userId="aa07a950-3061-465d-9845-1f16ea714d1e" providerId="ADAL" clId="{652E886E-EB52-40C6-999B-D6033CDA24D2}" dt="2026-09-11T08:30:56.715" v="1156" actId="404"/>
         <pc:sldMkLst>
           <pc:docMk/>
           <pc:sldMk cId="3622248180" sldId="531"/>
         </pc:sldMkLst>
-      </pc:sldChg>
-      <pc:sldChg chg="modSp mod modNotesTx">
-        <pc:chgData name="JORGE GALLUD CANO" userId="aa07a950-3061-465d-9845-1f16ea714d1e" providerId="ADAL" clId="{652E886E-EB52-40C6-999B-D6033CDA24D2}" dt="2025-09-15T08:46:30.525" v="189" actId="20577"/>
-        <pc:sldMkLst>
-          <pc:docMk/>
-          <pc:sldMk cId="481370698" sldId="532"/>
-        </pc:sldMkLst>
-      </pc:sldChg>
-      <pc:sldChg chg="modSp mod">
-        <pc:chgData name="JORGE GALLUD CANO" userId="aa07a950-3061-465d-9845-1f16ea714d1e" providerId="ADAL" clId="{652E886E-EB52-40C6-999B-D6033CDA24D2}" dt="2025-09-11T08:46:20.055" v="42" actId="20577"/>
-        <pc:sldMkLst>
-          <pc:docMk/>
-          <pc:sldMk cId="3728224116" sldId="533"/>
-        </pc:sldMkLst>
-      </pc:sldChg>
-      <pc:sldChg chg="modSp mod modNotesTx">
-        <pc:chgData name="JORGE GALLUD CANO" userId="aa07a950-3061-465d-9845-1f16ea714d1e" providerId="ADAL" clId="{652E886E-EB52-40C6-999B-D6033CDA24D2}" dt="2025-10-07T11:55:34.708" v="928" actId="6549"/>
-        <pc:sldMkLst>
-          <pc:docMk/>
-          <pc:sldMk cId="3386124033" sldId="534"/>
-        </pc:sldMkLst>
-        <pc:spChg chg="mod">
-          <ac:chgData name="JORGE GALLUD CANO" userId="aa07a950-3061-465d-9845-1f16ea714d1e" providerId="ADAL" clId="{652E886E-EB52-40C6-999B-D6033CDA24D2}" dt="2025-10-07T11:55:34.708" v="928" actId="6549"/>
+        <pc:spChg chg="add mod">
+          <ac:chgData name="JORGE GALLUD CANO" userId="aa07a950-3061-465d-9845-1f16ea714d1e" providerId="ADAL" clId="{652E886E-EB52-40C6-999B-D6033CDA24D2}" dt="2026-09-11T08:30:56.715" v="1156" actId="404"/>
           <ac:spMkLst>
             <pc:docMk/>
-            <pc:sldMk cId="3386124033" sldId="534"/>
-            <ac:spMk id="3" creationId="{00000000-0000-0000-0000-000000000000}"/>
+            <pc:sldMk cId="3622248180" sldId="531"/>
+            <ac:spMk id="4" creationId="{05D68C07-B7C5-F0F9-76DB-F255B5CBE83F}"/>
           </ac:spMkLst>
         </pc:spChg>
-      </pc:sldChg>
-      <pc:sldChg chg="modSp mod modNotesTx">
-        <pc:chgData name="JORGE GALLUD CANO" userId="aa07a950-3061-465d-9845-1f16ea714d1e" providerId="ADAL" clId="{652E886E-EB52-40C6-999B-D6033CDA24D2}" dt="2025-10-07T12:09:30.822" v="1121" actId="20577"/>
-        <pc:sldMkLst>
-          <pc:docMk/>
-          <pc:sldMk cId="3912472103" sldId="535"/>
-        </pc:sldMkLst>
-        <pc:spChg chg="mod">
-          <ac:chgData name="JORGE GALLUD CANO" userId="aa07a950-3061-465d-9845-1f16ea714d1e" providerId="ADAL" clId="{652E886E-EB52-40C6-999B-D6033CDA24D2}" dt="2025-10-07T12:08:18.100" v="978" actId="20577"/>
-          <ac:spMkLst>
+        <pc:graphicFrameChg chg="modGraphic">
+          <ac:chgData name="JORGE GALLUD CANO" userId="aa07a950-3061-465d-9845-1f16ea714d1e" providerId="ADAL" clId="{652E886E-EB52-40C6-999B-D6033CDA24D2}" dt="2026-09-11T08:29:04.645" v="1135" actId="20577"/>
+          <ac:graphicFrameMkLst>
             <pc:docMk/>
-            <pc:sldMk cId="3912472103" sldId="535"/>
-            <ac:spMk id="3" creationId="{00000000-0000-0000-0000-000000000000}"/>
-          </ac:spMkLst>
-        </pc:spChg>
-      </pc:sldChg>
-      <pc:sldChg chg="modSp add mod modNotesTx">
-        <pc:chgData name="JORGE GALLUD CANO" userId="aa07a950-3061-465d-9845-1f16ea714d1e" providerId="ADAL" clId="{652E886E-EB52-40C6-999B-D6033CDA24D2}" dt="2025-09-30T08:48:42.406" v="419" actId="20577"/>
-        <pc:sldMkLst>
-          <pc:docMk/>
-          <pc:sldMk cId="3226236516" sldId="542"/>
-        </pc:sldMkLst>
-        <pc:spChg chg="mod">
-          <ac:chgData name="JORGE GALLUD CANO" userId="aa07a950-3061-465d-9845-1f16ea714d1e" providerId="ADAL" clId="{652E886E-EB52-40C6-999B-D6033CDA24D2}" dt="2025-09-30T08:39:24.921" v="307"/>
-          <ac:spMkLst>
-            <pc:docMk/>
-            <pc:sldMk cId="3226236516" sldId="542"/>
-            <ac:spMk id="2" creationId="{557118AA-9A80-790A-AB91-A4AFB377FE5E}"/>
-          </ac:spMkLst>
-        </pc:spChg>
-        <pc:spChg chg="mod">
-          <ac:chgData name="JORGE GALLUD CANO" userId="aa07a950-3061-465d-9845-1f16ea714d1e" providerId="ADAL" clId="{652E886E-EB52-40C6-999B-D6033CDA24D2}" dt="2025-09-30T08:48:42.406" v="419" actId="20577"/>
-          <ac:spMkLst>
-            <pc:docMk/>
-            <pc:sldMk cId="3226236516" sldId="542"/>
-            <ac:spMk id="3" creationId="{79416648-15B8-9A30-4F79-27B0365345BD}"/>
-          </ac:spMkLst>
-        </pc:spChg>
-      </pc:sldChg>
-      <pc:sldChg chg="addSp modSp add mod">
-        <pc:chgData name="JORGE GALLUD CANO" userId="aa07a950-3061-465d-9845-1f16ea714d1e" providerId="ADAL" clId="{652E886E-EB52-40C6-999B-D6033CDA24D2}" dt="2025-09-30T09:11:37.978" v="927" actId="20577"/>
-        <pc:sldMkLst>
-          <pc:docMk/>
-          <pc:sldMk cId="1924007429" sldId="543"/>
-        </pc:sldMkLst>
-        <pc:spChg chg="mod">
-          <ac:chgData name="JORGE GALLUD CANO" userId="aa07a950-3061-465d-9845-1f16ea714d1e" providerId="ADAL" clId="{652E886E-EB52-40C6-999B-D6033CDA24D2}" dt="2025-09-30T08:49:54.079" v="487" actId="27636"/>
-          <ac:spMkLst>
-            <pc:docMk/>
-            <pc:sldMk cId="1924007429" sldId="543"/>
-            <ac:spMk id="2" creationId="{E1FF1D82-1D4F-1E5B-C229-555D7497D64D}"/>
-          </ac:spMkLst>
-        </pc:spChg>
-        <pc:spChg chg="mod">
-          <ac:chgData name="JORGE GALLUD CANO" userId="aa07a950-3061-465d-9845-1f16ea714d1e" providerId="ADAL" clId="{652E886E-EB52-40C6-999B-D6033CDA24D2}" dt="2025-09-30T09:11:37.978" v="927" actId="20577"/>
-          <ac:spMkLst>
-            <pc:docMk/>
-            <pc:sldMk cId="1924007429" sldId="543"/>
-            <ac:spMk id="3" creationId="{E07A3667-DE0D-77D2-75DF-67B3DD3C52C7}"/>
-          </ac:spMkLst>
-        </pc:spChg>
-      </pc:sldChg>
-      <pc:sldChg chg="modSp add mod">
-        <pc:chgData name="JORGE GALLUD CANO" userId="aa07a950-3061-465d-9845-1f16ea714d1e" providerId="ADAL" clId="{652E886E-EB52-40C6-999B-D6033CDA24D2}" dt="2025-10-07T11:56:19.500" v="943" actId="20577"/>
-        <pc:sldMkLst>
-          <pc:docMk/>
-          <pc:sldMk cId="1007362168" sldId="544"/>
-        </pc:sldMkLst>
-        <pc:spChg chg="mod">
-          <ac:chgData name="JORGE GALLUD CANO" userId="aa07a950-3061-465d-9845-1f16ea714d1e" providerId="ADAL" clId="{652E886E-EB52-40C6-999B-D6033CDA24D2}" dt="2025-09-30T09:07:47.101" v="796" actId="20577"/>
-          <ac:spMkLst>
-            <pc:docMk/>
-            <pc:sldMk cId="1007362168" sldId="544"/>
-            <ac:spMk id="2" creationId="{E1D61AB8-C442-0AA7-90F5-C65A569AACE3}"/>
-          </ac:spMkLst>
-        </pc:spChg>
-        <pc:spChg chg="mod">
-          <ac:chgData name="JORGE GALLUD CANO" userId="aa07a950-3061-465d-9845-1f16ea714d1e" providerId="ADAL" clId="{652E886E-EB52-40C6-999B-D6033CDA24D2}" dt="2025-10-07T11:56:19.500" v="943" actId="20577"/>
-          <ac:spMkLst>
-            <pc:docMk/>
-            <pc:sldMk cId="1007362168" sldId="544"/>
-            <ac:spMk id="3" creationId="{837E0865-3248-9A89-A9BA-D87BFC6AA792}"/>
-          </ac:spMkLst>
-        </pc:spChg>
-      </pc:sldChg>
-      <pc:sldChg chg="modSp add mod ord modNotesTx">
-        <pc:chgData name="JORGE GALLUD CANO" userId="aa07a950-3061-465d-9845-1f16ea714d1e" providerId="ADAL" clId="{652E886E-EB52-40C6-999B-D6033CDA24D2}" dt="2025-10-16T08:52:52.676" v="1132" actId="15"/>
-        <pc:sldMkLst>
-          <pc:docMk/>
-          <pc:sldMk cId="3568813608" sldId="549"/>
-        </pc:sldMkLst>
-        <pc:spChg chg="mod">
-          <ac:chgData name="JORGE GALLUD CANO" userId="aa07a950-3061-465d-9845-1f16ea714d1e" providerId="ADAL" clId="{652E886E-EB52-40C6-999B-D6033CDA24D2}" dt="2025-10-16T08:52:52.676" v="1132" actId="15"/>
-          <ac:spMkLst>
-            <pc:docMk/>
-            <pc:sldMk cId="3568813608" sldId="549"/>
-            <ac:spMk id="3" creationId="{5554B749-7EF6-55C5-8A41-FBCF61B72203}"/>
-          </ac:spMkLst>
-        </pc:spChg>
-      </pc:sldChg>
-    </pc:docChg>
-  </pc:docChgLst>
-  <pc:docChgLst>
-    <pc:chgData name="JORGE GALLUD CANO" userId="aa07a950-3061-465d-9845-1f16ea714d1e" providerId="ADAL" clId="{D5F518D7-5D08-48A0-AE37-FAC94EDFC64E}"/>
-    <pc:docChg chg="undo custSel addSld modSld sldOrd modNotesMaster modHandout">
-      <pc:chgData name="JORGE GALLUD CANO" userId="aa07a950-3061-465d-9845-1f16ea714d1e" providerId="ADAL" clId="{D5F518D7-5D08-48A0-AE37-FAC94EDFC64E}" dt="2025-10-22T21:33:34.851" v="1870" actId="6549"/>
-      <pc:docMkLst>
-        <pc:docMk/>
-      </pc:docMkLst>
-      <pc:sldChg chg="modSp mod">
-        <pc:chgData name="JORGE GALLUD CANO" userId="aa07a950-3061-465d-9845-1f16ea714d1e" providerId="ADAL" clId="{D5F518D7-5D08-48A0-AE37-FAC94EDFC64E}" dt="2025-09-14T14:16:46.950" v="185" actId="20577"/>
-        <pc:sldMkLst>
-          <pc:docMk/>
-          <pc:sldMk cId="579264008" sldId="263"/>
-        </pc:sldMkLst>
-      </pc:sldChg>
-      <pc:sldChg chg="modSp mod modNotesTx">
-        <pc:chgData name="JORGE GALLUD CANO" userId="aa07a950-3061-465d-9845-1f16ea714d1e" providerId="ADAL" clId="{D5F518D7-5D08-48A0-AE37-FAC94EDFC64E}" dt="2025-09-14T14:24:43.049" v="331" actId="20577"/>
-        <pc:sldMkLst>
-          <pc:docMk/>
-          <pc:sldMk cId="1005136347" sldId="287"/>
-        </pc:sldMkLst>
-      </pc:sldChg>
-      <pc:sldChg chg="modSp mod">
-        <pc:chgData name="JORGE GALLUD CANO" userId="aa07a950-3061-465d-9845-1f16ea714d1e" providerId="ADAL" clId="{D5F518D7-5D08-48A0-AE37-FAC94EDFC64E}" dt="2025-09-13T17:51:22.065" v="14" actId="20577"/>
-        <pc:sldMkLst>
-          <pc:docMk/>
-          <pc:sldMk cId="4031023037" sldId="514"/>
-        </pc:sldMkLst>
-      </pc:sldChg>
-      <pc:sldChg chg="modSp mod">
-        <pc:chgData name="JORGE GALLUD CANO" userId="aa07a950-3061-465d-9845-1f16ea714d1e" providerId="ADAL" clId="{D5F518D7-5D08-48A0-AE37-FAC94EDFC64E}" dt="2025-09-13T17:54:30.098" v="59" actId="20577"/>
-        <pc:sldMkLst>
-          <pc:docMk/>
-          <pc:sldMk cId="1231696929" sldId="526"/>
-        </pc:sldMkLst>
-      </pc:sldChg>
-      <pc:sldChg chg="modSp mod">
-        <pc:chgData name="JORGE GALLUD CANO" userId="aa07a950-3061-465d-9845-1f16ea714d1e" providerId="ADAL" clId="{D5F518D7-5D08-48A0-AE37-FAC94EDFC64E}" dt="2025-09-13T17:58:39.817" v="136" actId="20577"/>
-        <pc:sldMkLst>
-          <pc:docMk/>
-          <pc:sldMk cId="3622248180" sldId="531"/>
-        </pc:sldMkLst>
-      </pc:sldChg>
-      <pc:sldChg chg="modSp mod">
-        <pc:chgData name="JORGE GALLUD CANO" userId="aa07a950-3061-465d-9845-1f16ea714d1e" providerId="ADAL" clId="{D5F518D7-5D08-48A0-AE37-FAC94EDFC64E}" dt="2025-09-14T14:19:11.243" v="229" actId="20577"/>
-        <pc:sldMkLst>
-          <pc:docMk/>
-          <pc:sldMk cId="481370698" sldId="532"/>
-        </pc:sldMkLst>
-      </pc:sldChg>
-      <pc:sldChg chg="modSp mod">
-        <pc:chgData name="JORGE GALLUD CANO" userId="aa07a950-3061-465d-9845-1f16ea714d1e" providerId="ADAL" clId="{D5F518D7-5D08-48A0-AE37-FAC94EDFC64E}" dt="2025-09-14T14:27:43.365" v="378" actId="20577"/>
-        <pc:sldMkLst>
-          <pc:docMk/>
-          <pc:sldMk cId="3728224116" sldId="533"/>
-        </pc:sldMkLst>
-      </pc:sldChg>
-      <pc:sldChg chg="modSp mod modNotesTx">
-        <pc:chgData name="JORGE GALLUD CANO" userId="aa07a950-3061-465d-9845-1f16ea714d1e" providerId="ADAL" clId="{D5F518D7-5D08-48A0-AE37-FAC94EDFC64E}" dt="2025-10-08T08:55:45.098" v="944" actId="113"/>
-        <pc:sldMkLst>
-          <pc:docMk/>
-          <pc:sldMk cId="3912472103" sldId="535"/>
-        </pc:sldMkLst>
-        <pc:spChg chg="mod">
-          <ac:chgData name="JORGE GALLUD CANO" userId="aa07a950-3061-465d-9845-1f16ea714d1e" providerId="ADAL" clId="{D5F518D7-5D08-48A0-AE37-FAC94EDFC64E}" dt="2025-09-30T16:42:00.934" v="492" actId="20577"/>
-          <ac:spMkLst>
-            <pc:docMk/>
-            <pc:sldMk cId="3912472103" sldId="535"/>
-            <ac:spMk id="2" creationId="{00000000-0000-0000-0000-000000000000}"/>
-          </ac:spMkLst>
-        </pc:spChg>
-        <pc:spChg chg="mod">
-          <ac:chgData name="JORGE GALLUD CANO" userId="aa07a950-3061-465d-9845-1f16ea714d1e" providerId="ADAL" clId="{D5F518D7-5D08-48A0-AE37-FAC94EDFC64E}" dt="2025-10-08T08:55:45.098" v="944" actId="113"/>
-          <ac:spMkLst>
-            <pc:docMk/>
-            <pc:sldMk cId="3912472103" sldId="535"/>
-            <ac:spMk id="3" creationId="{00000000-0000-0000-0000-000000000000}"/>
-          </ac:spMkLst>
-        </pc:spChg>
-      </pc:sldChg>
-      <pc:sldChg chg="addSp delSp new mod ord">
-        <pc:chgData name="JORGE GALLUD CANO" userId="aa07a950-3061-465d-9845-1f16ea714d1e" providerId="ADAL" clId="{D5F518D7-5D08-48A0-AE37-FAC94EDFC64E}" dt="2025-09-14T16:04:49.912" v="385" actId="22"/>
-        <pc:sldMkLst>
-          <pc:docMk/>
-          <pc:sldMk cId="725519470" sldId="536"/>
-        </pc:sldMkLst>
-      </pc:sldChg>
-      <pc:sldChg chg="addSp add mod">
-        <pc:chgData name="JORGE GALLUD CANO" userId="aa07a950-3061-465d-9845-1f16ea714d1e" providerId="ADAL" clId="{D5F518D7-5D08-48A0-AE37-FAC94EDFC64E}" dt="2025-09-14T16:07:22.498" v="394" actId="22"/>
-        <pc:sldMkLst>
-          <pc:docMk/>
-          <pc:sldMk cId="3281597402" sldId="537"/>
-        </pc:sldMkLst>
-      </pc:sldChg>
-      <pc:sldChg chg="addSp delSp add mod">
-        <pc:chgData name="JORGE GALLUD CANO" userId="aa07a950-3061-465d-9845-1f16ea714d1e" providerId="ADAL" clId="{D5F518D7-5D08-48A0-AE37-FAC94EDFC64E}" dt="2025-09-14T16:05:18.817" v="390" actId="22"/>
-        <pc:sldMkLst>
-          <pc:docMk/>
-          <pc:sldMk cId="2889533622" sldId="538"/>
-        </pc:sldMkLst>
-      </pc:sldChg>
-      <pc:sldChg chg="addSp add mod">
-        <pc:chgData name="JORGE GALLUD CANO" userId="aa07a950-3061-465d-9845-1f16ea714d1e" providerId="ADAL" clId="{D5F518D7-5D08-48A0-AE37-FAC94EDFC64E}" dt="2025-09-14T16:05:51.224" v="392" actId="22"/>
-        <pc:sldMkLst>
-          <pc:docMk/>
-          <pc:sldMk cId="1421581604" sldId="539"/>
-        </pc:sldMkLst>
-      </pc:sldChg>
-      <pc:sldChg chg="addSp add mod">
-        <pc:chgData name="JORGE GALLUD CANO" userId="aa07a950-3061-465d-9845-1f16ea714d1e" providerId="ADAL" clId="{D5F518D7-5D08-48A0-AE37-FAC94EDFC64E}" dt="2025-09-14T16:05:36.107" v="391" actId="22"/>
-        <pc:sldMkLst>
-          <pc:docMk/>
-          <pc:sldMk cId="3472315297" sldId="540"/>
-        </pc:sldMkLst>
-      </pc:sldChg>
-      <pc:sldChg chg="addSp add mod">
-        <pc:chgData name="JORGE GALLUD CANO" userId="aa07a950-3061-465d-9845-1f16ea714d1e" providerId="ADAL" clId="{D5F518D7-5D08-48A0-AE37-FAC94EDFC64E}" dt="2025-09-14T16:07:42.710" v="395" actId="22"/>
-        <pc:sldMkLst>
-          <pc:docMk/>
-          <pc:sldMk cId="202022200" sldId="541"/>
-        </pc:sldMkLst>
-      </pc:sldChg>
-      <pc:sldChg chg="modSp mod">
-        <pc:chgData name="JORGE GALLUD CANO" userId="aa07a950-3061-465d-9845-1f16ea714d1e" providerId="ADAL" clId="{D5F518D7-5D08-48A0-AE37-FAC94EDFC64E}" dt="2025-10-07T09:51:05.324" v="578" actId="20577"/>
-        <pc:sldMkLst>
-          <pc:docMk/>
-          <pc:sldMk cId="1007362168" sldId="544"/>
-        </pc:sldMkLst>
-        <pc:spChg chg="mod">
-          <ac:chgData name="JORGE GALLUD CANO" userId="aa07a950-3061-465d-9845-1f16ea714d1e" providerId="ADAL" clId="{D5F518D7-5D08-48A0-AE37-FAC94EDFC64E}" dt="2025-10-07T09:51:05.324" v="578" actId="20577"/>
-          <ac:spMkLst>
-            <pc:docMk/>
-            <pc:sldMk cId="1007362168" sldId="544"/>
-            <ac:spMk id="3" creationId="{837E0865-3248-9A89-A9BA-D87BFC6AA792}"/>
-          </ac:spMkLst>
-        </pc:spChg>
-      </pc:sldChg>
-      <pc:sldChg chg="addSp modSp add mod ord modNotesTx">
-        <pc:chgData name="JORGE GALLUD CANO" userId="aa07a950-3061-465d-9845-1f16ea714d1e" providerId="ADAL" clId="{D5F518D7-5D08-48A0-AE37-FAC94EDFC64E}" dt="2025-10-22T21:33:34.851" v="1870" actId="6549"/>
-        <pc:sldMkLst>
-          <pc:docMk/>
-          <pc:sldMk cId="3716902506" sldId="545"/>
-        </pc:sldMkLst>
-        <pc:spChg chg="mod">
-          <ac:chgData name="JORGE GALLUD CANO" userId="aa07a950-3061-465d-9845-1f16ea714d1e" providerId="ADAL" clId="{D5F518D7-5D08-48A0-AE37-FAC94EDFC64E}" dt="2025-10-08T09:14:10.396" v="1151" actId="20577"/>
-          <ac:spMkLst>
-            <pc:docMk/>
-            <pc:sldMk cId="3716902506" sldId="545"/>
-            <ac:spMk id="2" creationId="{6E550F7B-26C7-91DA-28AE-F95F29E3C940}"/>
-          </ac:spMkLst>
-        </pc:spChg>
-        <pc:spChg chg="mod">
-          <ac:chgData name="JORGE GALLUD CANO" userId="aa07a950-3061-465d-9845-1f16ea714d1e" providerId="ADAL" clId="{D5F518D7-5D08-48A0-AE37-FAC94EDFC64E}" dt="2025-10-22T21:33:34.851" v="1870" actId="6549"/>
-          <ac:spMkLst>
-            <pc:docMk/>
-            <pc:sldMk cId="3716902506" sldId="545"/>
-            <ac:spMk id="3" creationId="{F705CCD7-9EA6-1D9A-EB61-7F736CE50083}"/>
-          </ac:spMkLst>
-        </pc:spChg>
-      </pc:sldChg>
-      <pc:sldChg chg="modSp add mod modNotesTx">
-        <pc:chgData name="JORGE GALLUD CANO" userId="aa07a950-3061-465d-9845-1f16ea714d1e" providerId="ADAL" clId="{D5F518D7-5D08-48A0-AE37-FAC94EDFC64E}" dt="2025-10-08T08:21:36.648" v="943" actId="20577"/>
-        <pc:sldMkLst>
-          <pc:docMk/>
-          <pc:sldMk cId="826327499" sldId="546"/>
-        </pc:sldMkLst>
-        <pc:spChg chg="mod">
-          <ac:chgData name="JORGE GALLUD CANO" userId="aa07a950-3061-465d-9845-1f16ea714d1e" providerId="ADAL" clId="{D5F518D7-5D08-48A0-AE37-FAC94EDFC64E}" dt="2025-10-08T08:21:36.648" v="943" actId="20577"/>
-          <ac:spMkLst>
-            <pc:docMk/>
-            <pc:sldMk cId="826327499" sldId="546"/>
-            <ac:spMk id="3" creationId="{73EB9147-60DC-7148-FD00-770248E4622E}"/>
-          </ac:spMkLst>
-        </pc:spChg>
-      </pc:sldChg>
-      <pc:sldChg chg="addSp modSp add mod">
-        <pc:chgData name="JORGE GALLUD CANO" userId="aa07a950-3061-465d-9845-1f16ea714d1e" providerId="ADAL" clId="{D5F518D7-5D08-48A0-AE37-FAC94EDFC64E}" dt="2025-10-09T09:47:43.924" v="1457" actId="20577"/>
-        <pc:sldMkLst>
-          <pc:docMk/>
-          <pc:sldMk cId="1252845018" sldId="547"/>
-        </pc:sldMkLst>
-        <pc:spChg chg="mod">
-          <ac:chgData name="JORGE GALLUD CANO" userId="aa07a950-3061-465d-9845-1f16ea714d1e" providerId="ADAL" clId="{D5F518D7-5D08-48A0-AE37-FAC94EDFC64E}" dt="2025-10-09T09:47:43.924" v="1457" actId="20577"/>
-          <ac:spMkLst>
-            <pc:docMk/>
-            <pc:sldMk cId="1252845018" sldId="547"/>
-            <ac:spMk id="3" creationId="{280481E2-3903-DDD9-9FD7-1DE359AF87D9}"/>
-          </ac:spMkLst>
-        </pc:spChg>
-      </pc:sldChg>
-      <pc:sldChg chg="addSp modSp add mod">
-        <pc:chgData name="JORGE GALLUD CANO" userId="aa07a950-3061-465d-9845-1f16ea714d1e" providerId="ADAL" clId="{D5F518D7-5D08-48A0-AE37-FAC94EDFC64E}" dt="2025-10-09T09:51:46.753" v="1535" actId="20577"/>
-        <pc:sldMkLst>
-          <pc:docMk/>
-          <pc:sldMk cId="1319511395" sldId="548"/>
-        </pc:sldMkLst>
-        <pc:spChg chg="mod">
-          <ac:chgData name="JORGE GALLUD CANO" userId="aa07a950-3061-465d-9845-1f16ea714d1e" providerId="ADAL" clId="{D5F518D7-5D08-48A0-AE37-FAC94EDFC64E}" dt="2025-10-09T09:51:46.753" v="1535" actId="20577"/>
-          <ac:spMkLst>
-            <pc:docMk/>
-            <pc:sldMk cId="1319511395" sldId="548"/>
-            <ac:spMk id="3" creationId="{EE7C1FC3-EC42-9A36-18F0-5F7AFAA6E7B0}"/>
-          </ac:spMkLst>
-        </pc:spChg>
-      </pc:sldChg>
-      <pc:sldChg chg="modSp mod ord modShow">
-        <pc:chgData name="JORGE GALLUD CANO" userId="aa07a950-3061-465d-9845-1f16ea714d1e" providerId="ADAL" clId="{D5F518D7-5D08-48A0-AE37-FAC94EDFC64E}" dt="2025-10-22T21:33:12.498" v="1869" actId="20577"/>
-        <pc:sldMkLst>
-          <pc:docMk/>
-          <pc:sldMk cId="3568813608" sldId="549"/>
-        </pc:sldMkLst>
-        <pc:spChg chg="mod">
-          <ac:chgData name="JORGE GALLUD CANO" userId="aa07a950-3061-465d-9845-1f16ea714d1e" providerId="ADAL" clId="{D5F518D7-5D08-48A0-AE37-FAC94EDFC64E}" dt="2025-10-22T21:33:12.498" v="1869" actId="20577"/>
-          <ac:spMkLst>
-            <pc:docMk/>
-            <pc:sldMk cId="3568813608" sldId="549"/>
-            <ac:spMk id="3" creationId="{5554B749-7EF6-55C5-8A41-FBCF61B72203}"/>
-          </ac:spMkLst>
-        </pc:spChg>
-      </pc:sldChg>
-      <pc:sldChg chg="modSp add mod">
-        <pc:chgData name="JORGE GALLUD CANO" userId="aa07a950-3061-465d-9845-1f16ea714d1e" providerId="ADAL" clId="{D5F518D7-5D08-48A0-AE37-FAC94EDFC64E}" dt="2025-10-21T09:09:52.677" v="1861" actId="947"/>
-        <pc:sldMkLst>
-          <pc:docMk/>
-          <pc:sldMk cId="315393847" sldId="550"/>
-        </pc:sldMkLst>
-        <pc:spChg chg="mod">
-          <ac:chgData name="JORGE GALLUD CANO" userId="aa07a950-3061-465d-9845-1f16ea714d1e" providerId="ADAL" clId="{D5F518D7-5D08-48A0-AE37-FAC94EDFC64E}" dt="2025-10-21T09:09:52.677" v="1861" actId="947"/>
-          <ac:spMkLst>
-            <pc:docMk/>
-            <pc:sldMk cId="315393847" sldId="550"/>
-            <ac:spMk id="2" creationId="{6118EB4F-A08E-3B18-F40C-6177D06DFB68}"/>
-          </ac:spMkLst>
-        </pc:spChg>
-        <pc:spChg chg="mod">
-          <ac:chgData name="JORGE GALLUD CANO" userId="aa07a950-3061-465d-9845-1f16ea714d1e" providerId="ADAL" clId="{D5F518D7-5D08-48A0-AE37-FAC94EDFC64E}" dt="2025-10-21T08:14:03.340" v="1838" actId="20577"/>
-          <ac:spMkLst>
-            <pc:docMk/>
-            <pc:sldMk cId="315393847" sldId="550"/>
-            <ac:spMk id="3" creationId="{72700188-2FD4-A744-E1F8-45ACF604F9A5}"/>
-          </ac:spMkLst>
-        </pc:spChg>
-      </pc:sldChg>
-      <pc:sldChg chg="modSp add mod">
-        <pc:chgData name="JORGE GALLUD CANO" userId="aa07a950-3061-465d-9845-1f16ea714d1e" providerId="ADAL" clId="{D5F518D7-5D08-48A0-AE37-FAC94EDFC64E}" dt="2025-10-20T09:19:36.776" v="1831" actId="20577"/>
-        <pc:sldMkLst>
-          <pc:docMk/>
-          <pc:sldMk cId="1588438122" sldId="551"/>
-        </pc:sldMkLst>
-        <pc:spChg chg="mod">
-          <ac:chgData name="JORGE GALLUD CANO" userId="aa07a950-3061-465d-9845-1f16ea714d1e" providerId="ADAL" clId="{D5F518D7-5D08-48A0-AE37-FAC94EDFC64E}" dt="2025-10-20T09:13:11.801" v="1797" actId="20577"/>
-          <ac:spMkLst>
-            <pc:docMk/>
-            <pc:sldMk cId="1588438122" sldId="551"/>
-            <ac:spMk id="2" creationId="{71640546-DDA7-6943-DE26-C730C796A1E7}"/>
-          </ac:spMkLst>
-        </pc:spChg>
-        <pc:spChg chg="mod">
-          <ac:chgData name="JORGE GALLUD CANO" userId="aa07a950-3061-465d-9845-1f16ea714d1e" providerId="ADAL" clId="{D5F518D7-5D08-48A0-AE37-FAC94EDFC64E}" dt="2025-10-20T09:19:36.776" v="1831" actId="20577"/>
-          <ac:spMkLst>
-            <pc:docMk/>
-            <pc:sldMk cId="1588438122" sldId="551"/>
-            <ac:spMk id="3" creationId="{5449F5C8-F84F-1142-6645-9B85B9232C56}"/>
-          </ac:spMkLst>
-        </pc:spChg>
-      </pc:sldChg>
-      <pc:sldChg chg="modSp add mod">
-        <pc:chgData name="JORGE GALLUD CANO" userId="aa07a950-3061-465d-9845-1f16ea714d1e" providerId="ADAL" clId="{D5F518D7-5D08-48A0-AE37-FAC94EDFC64E}" dt="2025-10-21T09:00:15.489" v="1860" actId="179"/>
-        <pc:sldMkLst>
-          <pc:docMk/>
-          <pc:sldMk cId="2333732718" sldId="552"/>
-        </pc:sldMkLst>
-        <pc:spChg chg="mod">
-          <ac:chgData name="JORGE GALLUD CANO" userId="aa07a950-3061-465d-9845-1f16ea714d1e" providerId="ADAL" clId="{D5F518D7-5D08-48A0-AE37-FAC94EDFC64E}" dt="2025-10-21T09:00:15.489" v="1860" actId="179"/>
-          <ac:spMkLst>
-            <pc:docMk/>
-            <pc:sldMk cId="2333732718" sldId="552"/>
-            <ac:spMk id="3" creationId="{2CDA9982-39B9-407F-413E-8E3F2D23A729}"/>
-          </ac:spMkLst>
-        </pc:spChg>
-      </pc:sldChg>
-    </pc:docChg>
-  </pc:docChgLst>
-  <pc:docChgLst>
-    <pc:chgData name="JORGE GALLUD CANO" userId="aa07a950-3061-465d-9845-1f16ea714d1e" providerId="ADAL" clId="{859700C9-EC16-442E-BCE8-F9EA4B9122D0}"/>
-    <pc:docChg chg="modSld modNotesMaster modHandout">
-      <pc:chgData name="JORGE GALLUD CANO" userId="aa07a950-3061-465d-9845-1f16ea714d1e" providerId="ADAL" clId="{859700C9-EC16-442E-BCE8-F9EA4B9122D0}" dt="2025-09-05T09:24:53.914" v="90"/>
-      <pc:docMkLst>
-        <pc:docMk/>
-      </pc:docMkLst>
-      <pc:sldChg chg="modSp mod">
-        <pc:chgData name="JORGE GALLUD CANO" userId="aa07a950-3061-465d-9845-1f16ea714d1e" providerId="ADAL" clId="{859700C9-EC16-442E-BCE8-F9EA4B9122D0}" dt="2025-09-02T10:12:08.410" v="47" actId="20577"/>
-        <pc:sldMkLst>
-          <pc:docMk/>
-          <pc:sldMk cId="1894586624" sldId="259"/>
-        </pc:sldMkLst>
-      </pc:sldChg>
-      <pc:sldChg chg="modSp mod">
-        <pc:chgData name="JORGE GALLUD CANO" userId="aa07a950-3061-465d-9845-1f16ea714d1e" providerId="ADAL" clId="{859700C9-EC16-442E-BCE8-F9EA4B9122D0}" dt="2025-09-02T10:13:28.288" v="77" actId="20577"/>
-        <pc:sldMkLst>
-          <pc:docMk/>
-          <pc:sldMk cId="4031023037" sldId="514"/>
-        </pc:sldMkLst>
-      </pc:sldChg>
-      <pc:sldChg chg="modSp mod">
-        <pc:chgData name="JORGE GALLUD CANO" userId="aa07a950-3061-465d-9845-1f16ea714d1e" providerId="ADAL" clId="{859700C9-EC16-442E-BCE8-F9EA4B9122D0}" dt="2025-09-03T10:59:53.425" v="82" actId="20577"/>
-        <pc:sldMkLst>
-          <pc:docMk/>
-          <pc:sldMk cId="1231696929" sldId="526"/>
-        </pc:sldMkLst>
-      </pc:sldChg>
-      <pc:sldChg chg="modSp mod">
-        <pc:chgData name="JORGE GALLUD CANO" userId="aa07a950-3061-465d-9845-1f16ea714d1e" providerId="ADAL" clId="{859700C9-EC16-442E-BCE8-F9EA4B9122D0}" dt="2025-09-02T10:11:49.794" v="28" actId="20577"/>
-        <pc:sldMkLst>
-          <pc:docMk/>
-          <pc:sldMk cId="3622248180" sldId="531"/>
-        </pc:sldMkLst>
-      </pc:sldChg>
-      <pc:sldChg chg="modSp mod">
-        <pc:chgData name="JORGE GALLUD CANO" userId="aa07a950-3061-465d-9845-1f16ea714d1e" providerId="ADAL" clId="{859700C9-EC16-442E-BCE8-F9EA4B9122D0}" dt="2025-09-03T11:01:25.704" v="88" actId="20577"/>
-        <pc:sldMkLst>
-          <pc:docMk/>
-          <pc:sldMk cId="481370698" sldId="532"/>
-        </pc:sldMkLst>
-      </pc:sldChg>
-    </pc:docChg>
-  </pc:docChgLst>
-  <pc:docChgLst>
-    <pc:chgData name="JORGE GALLUD CANO" userId="aa07a950-3061-465d-9845-1f16ea714d1e" providerId="ADAL" clId="{1CFD8AD4-65FA-413A-997A-ED6E8D0F0946}"/>
-    <pc:docChg chg="undo custSel addSld delSld">
-      <pc:chgData name="JORGE GALLUD CANO" userId="aa07a950-3061-465d-9845-1f16ea714d1e" providerId="ADAL" clId="{1CFD8AD4-65FA-413A-997A-ED6E8D0F0946}" dt="2025-08-23T09:47:42.228" v="8" actId="47"/>
-      <pc:docMkLst>
-        <pc:docMk/>
-      </pc:docMkLst>
-      <pc:sldChg chg="add del">
-        <pc:chgData name="JORGE GALLUD CANO" userId="aa07a950-3061-465d-9845-1f16ea714d1e" providerId="ADAL" clId="{1CFD8AD4-65FA-413A-997A-ED6E8D0F0946}" dt="2025-08-23T09:47:42.228" v="8" actId="47"/>
-        <pc:sldMkLst>
-          <pc:docMk/>
-          <pc:sldMk cId="3087793293" sldId="260"/>
-        </pc:sldMkLst>
-      </pc:sldChg>
-      <pc:sldChg chg="del">
-        <pc:chgData name="JORGE GALLUD CANO" userId="aa07a950-3061-465d-9845-1f16ea714d1e" providerId="ADAL" clId="{1CFD8AD4-65FA-413A-997A-ED6E8D0F0946}" dt="2025-08-23T09:47:11.866" v="0" actId="47"/>
-        <pc:sldMkLst>
-          <pc:docMk/>
-          <pc:sldMk cId="3150193090" sldId="261"/>
-        </pc:sldMkLst>
-      </pc:sldChg>
-      <pc:sldChg chg="del">
-        <pc:chgData name="JORGE GALLUD CANO" userId="aa07a950-3061-465d-9845-1f16ea714d1e" providerId="ADAL" clId="{1CFD8AD4-65FA-413A-997A-ED6E8D0F0946}" dt="2025-08-23T09:47:11.866" v="0" actId="47"/>
-        <pc:sldMkLst>
-          <pc:docMk/>
-          <pc:sldMk cId="594737123" sldId="262"/>
-        </pc:sldMkLst>
-      </pc:sldChg>
-      <pc:sldChg chg="del">
-        <pc:chgData name="JORGE GALLUD CANO" userId="aa07a950-3061-465d-9845-1f16ea714d1e" providerId="ADAL" clId="{1CFD8AD4-65FA-413A-997A-ED6E8D0F0946}" dt="2025-08-23T09:47:15.259" v="1" actId="47"/>
-        <pc:sldMkLst>
-          <pc:docMk/>
-          <pc:sldMk cId="3467514994" sldId="264"/>
-        </pc:sldMkLst>
-      </pc:sldChg>
-      <pc:sldChg chg="del">
-        <pc:chgData name="JORGE GALLUD CANO" userId="aa07a950-3061-465d-9845-1f16ea714d1e" providerId="ADAL" clId="{1CFD8AD4-65FA-413A-997A-ED6E8D0F0946}" dt="2025-08-23T09:47:11.866" v="0" actId="47"/>
-        <pc:sldMkLst>
-          <pc:docMk/>
-          <pc:sldMk cId="2631823192" sldId="265"/>
-        </pc:sldMkLst>
-      </pc:sldChg>
-      <pc:sldChg chg="del">
-        <pc:chgData name="JORGE GALLUD CANO" userId="aa07a950-3061-465d-9845-1f16ea714d1e" providerId="ADAL" clId="{1CFD8AD4-65FA-413A-997A-ED6E8D0F0946}" dt="2025-08-23T09:47:11.866" v="0" actId="47"/>
-        <pc:sldMkLst>
-          <pc:docMk/>
-          <pc:sldMk cId="706568294" sldId="266"/>
-        </pc:sldMkLst>
-      </pc:sldChg>
-      <pc:sldChg chg="del">
-        <pc:chgData name="JORGE GALLUD CANO" userId="aa07a950-3061-465d-9845-1f16ea714d1e" providerId="ADAL" clId="{1CFD8AD4-65FA-413A-997A-ED6E8D0F0946}" dt="2025-08-23T09:47:11.866" v="0" actId="47"/>
-        <pc:sldMkLst>
-          <pc:docMk/>
-          <pc:sldMk cId="1848052176" sldId="267"/>
-        </pc:sldMkLst>
-      </pc:sldChg>
-      <pc:sldChg chg="del">
-        <pc:chgData name="JORGE GALLUD CANO" userId="aa07a950-3061-465d-9845-1f16ea714d1e" providerId="ADAL" clId="{1CFD8AD4-65FA-413A-997A-ED6E8D0F0946}" dt="2025-08-23T09:47:15.259" v="1" actId="47"/>
-        <pc:sldMkLst>
-          <pc:docMk/>
-          <pc:sldMk cId="2055150764" sldId="268"/>
-        </pc:sldMkLst>
-      </pc:sldChg>
-      <pc:sldChg chg="del">
-        <pc:chgData name="JORGE GALLUD CANO" userId="aa07a950-3061-465d-9845-1f16ea714d1e" providerId="ADAL" clId="{1CFD8AD4-65FA-413A-997A-ED6E8D0F0946}" dt="2025-08-23T09:47:29.664" v="4" actId="47"/>
-        <pc:sldMkLst>
-          <pc:docMk/>
-          <pc:sldMk cId="1220813665" sldId="269"/>
-        </pc:sldMkLst>
-      </pc:sldChg>
-      <pc:sldChg chg="del">
-        <pc:chgData name="JORGE GALLUD CANO" userId="aa07a950-3061-465d-9845-1f16ea714d1e" providerId="ADAL" clId="{1CFD8AD4-65FA-413A-997A-ED6E8D0F0946}" dt="2025-08-23T09:47:29.664" v="4" actId="47"/>
-        <pc:sldMkLst>
-          <pc:docMk/>
-          <pc:sldMk cId="1599127546" sldId="270"/>
-        </pc:sldMkLst>
-      </pc:sldChg>
-      <pc:sldChg chg="del">
-        <pc:chgData name="JORGE GALLUD CANO" userId="aa07a950-3061-465d-9845-1f16ea714d1e" providerId="ADAL" clId="{1CFD8AD4-65FA-413A-997A-ED6E8D0F0946}" dt="2025-08-23T09:47:29.664" v="4" actId="47"/>
-        <pc:sldMkLst>
-          <pc:docMk/>
-          <pc:sldMk cId="0" sldId="304"/>
-        </pc:sldMkLst>
-      </pc:sldChg>
-      <pc:sldChg chg="del">
-        <pc:chgData name="JORGE GALLUD CANO" userId="aa07a950-3061-465d-9845-1f16ea714d1e" providerId="ADAL" clId="{1CFD8AD4-65FA-413A-997A-ED6E8D0F0946}" dt="2025-08-23T09:47:29.664" v="4" actId="47"/>
-        <pc:sldMkLst>
-          <pc:docMk/>
-          <pc:sldMk cId="1952336111" sldId="315"/>
-        </pc:sldMkLst>
-      </pc:sldChg>
-      <pc:sldChg chg="del">
-        <pc:chgData name="JORGE GALLUD CANO" userId="aa07a950-3061-465d-9845-1f16ea714d1e" providerId="ADAL" clId="{1CFD8AD4-65FA-413A-997A-ED6E8D0F0946}" dt="2025-08-23T09:47:29.664" v="4" actId="47"/>
-        <pc:sldMkLst>
-          <pc:docMk/>
-          <pc:sldMk cId="3801989857" sldId="316"/>
-        </pc:sldMkLst>
-      </pc:sldChg>
-      <pc:sldChg chg="del">
-        <pc:chgData name="JORGE GALLUD CANO" userId="aa07a950-3061-465d-9845-1f16ea714d1e" providerId="ADAL" clId="{1CFD8AD4-65FA-413A-997A-ED6E8D0F0946}" dt="2025-08-23T09:47:29.664" v="4" actId="47"/>
-        <pc:sldMkLst>
-          <pc:docMk/>
-          <pc:sldMk cId="0" sldId="317"/>
-        </pc:sldMkLst>
-      </pc:sldChg>
-      <pc:sldChg chg="del">
-        <pc:chgData name="JORGE GALLUD CANO" userId="aa07a950-3061-465d-9845-1f16ea714d1e" providerId="ADAL" clId="{1CFD8AD4-65FA-413A-997A-ED6E8D0F0946}" dt="2025-08-23T09:47:29.664" v="4" actId="47"/>
-        <pc:sldMkLst>
-          <pc:docMk/>
-          <pc:sldMk cId="0" sldId="318"/>
-        </pc:sldMkLst>
-      </pc:sldChg>
-      <pc:sldChg chg="del">
-        <pc:chgData name="JORGE GALLUD CANO" userId="aa07a950-3061-465d-9845-1f16ea714d1e" providerId="ADAL" clId="{1CFD8AD4-65FA-413A-997A-ED6E8D0F0946}" dt="2025-08-23T09:47:29.664" v="4" actId="47"/>
-        <pc:sldMkLst>
-          <pc:docMk/>
-          <pc:sldMk cId="0" sldId="319"/>
-        </pc:sldMkLst>
-      </pc:sldChg>
-      <pc:sldChg chg="del">
-        <pc:chgData name="JORGE GALLUD CANO" userId="aa07a950-3061-465d-9845-1f16ea714d1e" providerId="ADAL" clId="{1CFD8AD4-65FA-413A-997A-ED6E8D0F0946}" dt="2025-08-23T09:47:34.243" v="5" actId="47"/>
-        <pc:sldMkLst>
-          <pc:docMk/>
-          <pc:sldMk cId="2013899992" sldId="321"/>
-        </pc:sldMkLst>
-      </pc:sldChg>
-      <pc:sldChg chg="del">
-        <pc:chgData name="JORGE GALLUD CANO" userId="aa07a950-3061-465d-9845-1f16ea714d1e" providerId="ADAL" clId="{1CFD8AD4-65FA-413A-997A-ED6E8D0F0946}" dt="2025-08-23T09:47:34.243" v="5" actId="47"/>
-        <pc:sldMkLst>
-          <pc:docMk/>
-          <pc:sldMk cId="3885165775" sldId="322"/>
-        </pc:sldMkLst>
-      </pc:sldChg>
-      <pc:sldChg chg="del">
-        <pc:chgData name="JORGE GALLUD CANO" userId="aa07a950-3061-465d-9845-1f16ea714d1e" providerId="ADAL" clId="{1CFD8AD4-65FA-413A-997A-ED6E8D0F0946}" dt="2025-08-23T09:47:34.243" v="5" actId="47"/>
-        <pc:sldMkLst>
-          <pc:docMk/>
-          <pc:sldMk cId="0" sldId="323"/>
-        </pc:sldMkLst>
-      </pc:sldChg>
-      <pc:sldChg chg="del">
-        <pc:chgData name="JORGE GALLUD CANO" userId="aa07a950-3061-465d-9845-1f16ea714d1e" providerId="ADAL" clId="{1CFD8AD4-65FA-413A-997A-ED6E8D0F0946}" dt="2025-08-23T09:47:34.243" v="5" actId="47"/>
-        <pc:sldMkLst>
-          <pc:docMk/>
-          <pc:sldMk cId="0" sldId="324"/>
-        </pc:sldMkLst>
-      </pc:sldChg>
-      <pc:sldChg chg="del">
-        <pc:chgData name="JORGE GALLUD CANO" userId="aa07a950-3061-465d-9845-1f16ea714d1e" providerId="ADAL" clId="{1CFD8AD4-65FA-413A-997A-ED6E8D0F0946}" dt="2025-08-23T09:47:34.243" v="5" actId="47"/>
-        <pc:sldMkLst>
-          <pc:docMk/>
-          <pc:sldMk cId="0" sldId="325"/>
-        </pc:sldMkLst>
-      </pc:sldChg>
-      <pc:sldChg chg="del">
-        <pc:chgData name="JORGE GALLUD CANO" userId="aa07a950-3061-465d-9845-1f16ea714d1e" providerId="ADAL" clId="{1CFD8AD4-65FA-413A-997A-ED6E8D0F0946}" dt="2025-08-23T09:47:34.243" v="5" actId="47"/>
-        <pc:sldMkLst>
-          <pc:docMk/>
-          <pc:sldMk cId="0" sldId="326"/>
-        </pc:sldMkLst>
-      </pc:sldChg>
-      <pc:sldChg chg="del">
-        <pc:chgData name="JORGE GALLUD CANO" userId="aa07a950-3061-465d-9845-1f16ea714d1e" providerId="ADAL" clId="{1CFD8AD4-65FA-413A-997A-ED6E8D0F0946}" dt="2025-08-23T09:47:34.243" v="5" actId="47"/>
-        <pc:sldMkLst>
-          <pc:docMk/>
-          <pc:sldMk cId="0" sldId="336"/>
-        </pc:sldMkLst>
-      </pc:sldChg>
-      <pc:sldChg chg="del">
-        <pc:chgData name="JORGE GALLUD CANO" userId="aa07a950-3061-465d-9845-1f16ea714d1e" providerId="ADAL" clId="{1CFD8AD4-65FA-413A-997A-ED6E8D0F0946}" dt="2025-08-23T09:47:34.243" v="5" actId="47"/>
-        <pc:sldMkLst>
-          <pc:docMk/>
-          <pc:sldMk cId="0" sldId="339"/>
-        </pc:sldMkLst>
-      </pc:sldChg>
-      <pc:sldChg chg="del">
-        <pc:chgData name="JORGE GALLUD CANO" userId="aa07a950-3061-465d-9845-1f16ea714d1e" providerId="ADAL" clId="{1CFD8AD4-65FA-413A-997A-ED6E8D0F0946}" dt="2025-08-23T09:47:29.664" v="4" actId="47"/>
-        <pc:sldMkLst>
-          <pc:docMk/>
-          <pc:sldMk cId="4021750541" sldId="369"/>
-        </pc:sldMkLst>
-      </pc:sldChg>
-      <pc:sldChg chg="del">
-        <pc:chgData name="JORGE GALLUD CANO" userId="aa07a950-3061-465d-9845-1f16ea714d1e" providerId="ADAL" clId="{1CFD8AD4-65FA-413A-997A-ED6E8D0F0946}" dt="2025-08-23T09:47:29.664" v="4" actId="47"/>
-        <pc:sldMkLst>
-          <pc:docMk/>
-          <pc:sldMk cId="2785731025" sldId="370"/>
-        </pc:sldMkLst>
-      </pc:sldChg>
-      <pc:sldChg chg="del">
-        <pc:chgData name="JORGE GALLUD CANO" userId="aa07a950-3061-465d-9845-1f16ea714d1e" providerId="ADAL" clId="{1CFD8AD4-65FA-413A-997A-ED6E8D0F0946}" dt="2025-08-23T09:47:34.243" v="5" actId="47"/>
-        <pc:sldMkLst>
-          <pc:docMk/>
-          <pc:sldMk cId="2607650453" sldId="371"/>
-        </pc:sldMkLst>
-      </pc:sldChg>
-      <pc:sldChg chg="del">
-        <pc:chgData name="JORGE GALLUD CANO" userId="aa07a950-3061-465d-9845-1f16ea714d1e" providerId="ADAL" clId="{1CFD8AD4-65FA-413A-997A-ED6E8D0F0946}" dt="2025-08-23T09:47:34.243" v="5" actId="47"/>
-        <pc:sldMkLst>
-          <pc:docMk/>
-          <pc:sldMk cId="863811219" sldId="372"/>
-        </pc:sldMkLst>
-      </pc:sldChg>
-      <pc:sldChg chg="del">
-        <pc:chgData name="JORGE GALLUD CANO" userId="aa07a950-3061-465d-9845-1f16ea714d1e" providerId="ADAL" clId="{1CFD8AD4-65FA-413A-997A-ED6E8D0F0946}" dt="2025-08-23T09:47:34.243" v="5" actId="47"/>
-        <pc:sldMkLst>
-          <pc:docMk/>
-          <pc:sldMk cId="2391918928" sldId="373"/>
-        </pc:sldMkLst>
-      </pc:sldChg>
-      <pc:sldChg chg="del">
-        <pc:chgData name="JORGE GALLUD CANO" userId="aa07a950-3061-465d-9845-1f16ea714d1e" providerId="ADAL" clId="{1CFD8AD4-65FA-413A-997A-ED6E8D0F0946}" dt="2025-08-23T09:47:34.243" v="5" actId="47"/>
-        <pc:sldMkLst>
-          <pc:docMk/>
-          <pc:sldMk cId="845031517" sldId="374"/>
-        </pc:sldMkLst>
-      </pc:sldChg>
-      <pc:sldChg chg="del">
-        <pc:chgData name="JORGE GALLUD CANO" userId="aa07a950-3061-465d-9845-1f16ea714d1e" providerId="ADAL" clId="{1CFD8AD4-65FA-413A-997A-ED6E8D0F0946}" dt="2025-08-23T09:47:34.243" v="5" actId="47"/>
-        <pc:sldMkLst>
-          <pc:docMk/>
-          <pc:sldMk cId="537315646" sldId="375"/>
-        </pc:sldMkLst>
-      </pc:sldChg>
-      <pc:sldChg chg="del">
-        <pc:chgData name="JORGE GALLUD CANO" userId="aa07a950-3061-465d-9845-1f16ea714d1e" providerId="ADAL" clId="{1CFD8AD4-65FA-413A-997A-ED6E8D0F0946}" dt="2025-08-23T09:47:15.259" v="1" actId="47"/>
-        <pc:sldMkLst>
-          <pc:docMk/>
-          <pc:sldMk cId="707880807" sldId="536"/>
-        </pc:sldMkLst>
-      </pc:sldChg>
-      <pc:sldChg chg="del">
-        <pc:chgData name="JORGE GALLUD CANO" userId="aa07a950-3061-465d-9845-1f16ea714d1e" providerId="ADAL" clId="{1CFD8AD4-65FA-413A-997A-ED6E8D0F0946}" dt="2025-08-23T09:47:15.259" v="1" actId="47"/>
-        <pc:sldMkLst>
-          <pc:docMk/>
-          <pc:sldMk cId="465850784" sldId="537"/>
-        </pc:sldMkLst>
-      </pc:sldChg>
-      <pc:sldChg chg="del">
-        <pc:chgData name="JORGE GALLUD CANO" userId="aa07a950-3061-465d-9845-1f16ea714d1e" providerId="ADAL" clId="{1CFD8AD4-65FA-413A-997A-ED6E8D0F0946}" dt="2025-08-23T09:47:15.259" v="1" actId="47"/>
-        <pc:sldMkLst>
-          <pc:docMk/>
-          <pc:sldMk cId="4067792214" sldId="538"/>
-        </pc:sldMkLst>
-      </pc:sldChg>
-      <pc:sldChg chg="del">
-        <pc:chgData name="JORGE GALLUD CANO" userId="aa07a950-3061-465d-9845-1f16ea714d1e" providerId="ADAL" clId="{1CFD8AD4-65FA-413A-997A-ED6E8D0F0946}" dt="2025-08-23T09:47:15.259" v="1" actId="47"/>
-        <pc:sldMkLst>
-          <pc:docMk/>
-          <pc:sldMk cId="1448990937" sldId="539"/>
-        </pc:sldMkLst>
-      </pc:sldChg>
-      <pc:sldChg chg="del">
-        <pc:chgData name="JORGE GALLUD CANO" userId="aa07a950-3061-465d-9845-1f16ea714d1e" providerId="ADAL" clId="{1CFD8AD4-65FA-413A-997A-ED6E8D0F0946}" dt="2025-08-23T09:47:15.259" v="1" actId="47"/>
-        <pc:sldMkLst>
-          <pc:docMk/>
-          <pc:sldMk cId="955192983" sldId="540"/>
-        </pc:sldMkLst>
-      </pc:sldChg>
-      <pc:sldChg chg="del">
-        <pc:chgData name="JORGE GALLUD CANO" userId="aa07a950-3061-465d-9845-1f16ea714d1e" providerId="ADAL" clId="{1CFD8AD4-65FA-413A-997A-ED6E8D0F0946}" dt="2025-08-23T09:47:15.259" v="1" actId="47"/>
-        <pc:sldMkLst>
-          <pc:docMk/>
-          <pc:sldMk cId="3848481124" sldId="541"/>
-        </pc:sldMkLst>
-      </pc:sldChg>
-      <pc:sldChg chg="del">
-        <pc:chgData name="JORGE GALLUD CANO" userId="aa07a950-3061-465d-9845-1f16ea714d1e" providerId="ADAL" clId="{1CFD8AD4-65FA-413A-997A-ED6E8D0F0946}" dt="2025-08-23T09:47:15.259" v="1" actId="47"/>
-        <pc:sldMkLst>
-          <pc:docMk/>
-          <pc:sldMk cId="1306932417" sldId="542"/>
-        </pc:sldMkLst>
-      </pc:sldChg>
-      <pc:sldChg chg="del">
-        <pc:chgData name="JORGE GALLUD CANO" userId="aa07a950-3061-465d-9845-1f16ea714d1e" providerId="ADAL" clId="{1CFD8AD4-65FA-413A-997A-ED6E8D0F0946}" dt="2025-08-23T09:47:17.882" v="2" actId="47"/>
-        <pc:sldMkLst>
-          <pc:docMk/>
-          <pc:sldMk cId="112043818" sldId="543"/>
-        </pc:sldMkLst>
-      </pc:sldChg>
-      <pc:sldChg chg="del">
-        <pc:chgData name="JORGE GALLUD CANO" userId="aa07a950-3061-465d-9845-1f16ea714d1e" providerId="ADAL" clId="{1CFD8AD4-65FA-413A-997A-ED6E8D0F0946}" dt="2025-08-23T09:47:17.882" v="2" actId="47"/>
-        <pc:sldMkLst>
-          <pc:docMk/>
-          <pc:sldMk cId="3834304839" sldId="544"/>
-        </pc:sldMkLst>
-      </pc:sldChg>
-      <pc:sldChg chg="del">
-        <pc:chgData name="JORGE GALLUD CANO" userId="aa07a950-3061-465d-9845-1f16ea714d1e" providerId="ADAL" clId="{1CFD8AD4-65FA-413A-997A-ED6E8D0F0946}" dt="2025-08-23T09:47:17.882" v="2" actId="47"/>
-        <pc:sldMkLst>
-          <pc:docMk/>
-          <pc:sldMk cId="2999834531" sldId="545"/>
-        </pc:sldMkLst>
-      </pc:sldChg>
-      <pc:sldChg chg="del">
-        <pc:chgData name="JORGE GALLUD CANO" userId="aa07a950-3061-465d-9845-1f16ea714d1e" providerId="ADAL" clId="{1CFD8AD4-65FA-413A-997A-ED6E8D0F0946}" dt="2025-08-23T09:47:17.882" v="2" actId="47"/>
-        <pc:sldMkLst>
-          <pc:docMk/>
-          <pc:sldMk cId="3977175055" sldId="546"/>
-        </pc:sldMkLst>
-      </pc:sldChg>
-      <pc:sldChg chg="del">
-        <pc:chgData name="JORGE GALLUD CANO" userId="aa07a950-3061-465d-9845-1f16ea714d1e" providerId="ADAL" clId="{1CFD8AD4-65FA-413A-997A-ED6E8D0F0946}" dt="2025-08-23T09:47:17.882" v="2" actId="47"/>
-        <pc:sldMkLst>
-          <pc:docMk/>
-          <pc:sldMk cId="1563079690" sldId="547"/>
-        </pc:sldMkLst>
-      </pc:sldChg>
-      <pc:sldChg chg="del">
-        <pc:chgData name="JORGE GALLUD CANO" userId="aa07a950-3061-465d-9845-1f16ea714d1e" providerId="ADAL" clId="{1CFD8AD4-65FA-413A-997A-ED6E8D0F0946}" dt="2025-08-23T09:47:17.882" v="2" actId="47"/>
-        <pc:sldMkLst>
-          <pc:docMk/>
-          <pc:sldMk cId="608954207" sldId="548"/>
-        </pc:sldMkLst>
-      </pc:sldChg>
-      <pc:sldChg chg="del">
-        <pc:chgData name="JORGE GALLUD CANO" userId="aa07a950-3061-465d-9845-1f16ea714d1e" providerId="ADAL" clId="{1CFD8AD4-65FA-413A-997A-ED6E8D0F0946}" dt="2025-08-23T09:47:17.882" v="2" actId="47"/>
-        <pc:sldMkLst>
-          <pc:docMk/>
-          <pc:sldMk cId="2495028577" sldId="549"/>
-        </pc:sldMkLst>
-      </pc:sldChg>
-      <pc:sldChg chg="del">
-        <pc:chgData name="JORGE GALLUD CANO" userId="aa07a950-3061-465d-9845-1f16ea714d1e" providerId="ADAL" clId="{1CFD8AD4-65FA-413A-997A-ED6E8D0F0946}" dt="2025-08-23T09:47:17.882" v="2" actId="47"/>
-        <pc:sldMkLst>
-          <pc:docMk/>
-          <pc:sldMk cId="198734755" sldId="550"/>
-        </pc:sldMkLst>
-      </pc:sldChg>
-      <pc:sldChg chg="del">
-        <pc:chgData name="JORGE GALLUD CANO" userId="aa07a950-3061-465d-9845-1f16ea714d1e" providerId="ADAL" clId="{1CFD8AD4-65FA-413A-997A-ED6E8D0F0946}" dt="2025-08-23T09:47:17.882" v="2" actId="47"/>
-        <pc:sldMkLst>
-          <pc:docMk/>
-          <pc:sldMk cId="2871274626" sldId="551"/>
-        </pc:sldMkLst>
-      </pc:sldChg>
-      <pc:sldChg chg="del">
-        <pc:chgData name="JORGE GALLUD CANO" userId="aa07a950-3061-465d-9845-1f16ea714d1e" providerId="ADAL" clId="{1CFD8AD4-65FA-413A-997A-ED6E8D0F0946}" dt="2025-08-23T09:47:22.550" v="3" actId="47"/>
-        <pc:sldMkLst>
-          <pc:docMk/>
-          <pc:sldMk cId="585274247" sldId="552"/>
-        </pc:sldMkLst>
-      </pc:sldChg>
-      <pc:sldChg chg="del">
-        <pc:chgData name="JORGE GALLUD CANO" userId="aa07a950-3061-465d-9845-1f16ea714d1e" providerId="ADAL" clId="{1CFD8AD4-65FA-413A-997A-ED6E8D0F0946}" dt="2025-08-23T09:47:22.550" v="3" actId="47"/>
-        <pc:sldMkLst>
-          <pc:docMk/>
-          <pc:sldMk cId="727437492" sldId="553"/>
-        </pc:sldMkLst>
-      </pc:sldChg>
-      <pc:sldChg chg="del">
-        <pc:chgData name="JORGE GALLUD CANO" userId="aa07a950-3061-465d-9845-1f16ea714d1e" providerId="ADAL" clId="{1CFD8AD4-65FA-413A-997A-ED6E8D0F0946}" dt="2025-08-23T09:47:22.550" v="3" actId="47"/>
-        <pc:sldMkLst>
-          <pc:docMk/>
-          <pc:sldMk cId="1405569845" sldId="554"/>
-        </pc:sldMkLst>
-      </pc:sldChg>
-      <pc:sldChg chg="del">
-        <pc:chgData name="JORGE GALLUD CANO" userId="aa07a950-3061-465d-9845-1f16ea714d1e" providerId="ADAL" clId="{1CFD8AD4-65FA-413A-997A-ED6E8D0F0946}" dt="2025-08-23T09:47:22.550" v="3" actId="47"/>
-        <pc:sldMkLst>
-          <pc:docMk/>
-          <pc:sldMk cId="1757646886" sldId="555"/>
-        </pc:sldMkLst>
-      </pc:sldChg>
-      <pc:sldChg chg="del">
-        <pc:chgData name="JORGE GALLUD CANO" userId="aa07a950-3061-465d-9845-1f16ea714d1e" providerId="ADAL" clId="{1CFD8AD4-65FA-413A-997A-ED6E8D0F0946}" dt="2025-08-23T09:47:22.550" v="3" actId="47"/>
-        <pc:sldMkLst>
-          <pc:docMk/>
-          <pc:sldMk cId="498805622" sldId="556"/>
-        </pc:sldMkLst>
-      </pc:sldChg>
-      <pc:sldChg chg="del">
-        <pc:chgData name="JORGE GALLUD CANO" userId="aa07a950-3061-465d-9845-1f16ea714d1e" providerId="ADAL" clId="{1CFD8AD4-65FA-413A-997A-ED6E8D0F0946}" dt="2025-08-23T09:47:22.550" v="3" actId="47"/>
-        <pc:sldMkLst>
-          <pc:docMk/>
-          <pc:sldMk cId="3980255656" sldId="557"/>
-        </pc:sldMkLst>
-      </pc:sldChg>
-      <pc:sldChg chg="del">
-        <pc:chgData name="JORGE GALLUD CANO" userId="aa07a950-3061-465d-9845-1f16ea714d1e" providerId="ADAL" clId="{1CFD8AD4-65FA-413A-997A-ED6E8D0F0946}" dt="2025-08-23T09:47:22.550" v="3" actId="47"/>
-        <pc:sldMkLst>
-          <pc:docMk/>
-          <pc:sldMk cId="572385549" sldId="558"/>
-        </pc:sldMkLst>
-      </pc:sldChg>
-      <pc:sldChg chg="del">
-        <pc:chgData name="JORGE GALLUD CANO" userId="aa07a950-3061-465d-9845-1f16ea714d1e" providerId="ADAL" clId="{1CFD8AD4-65FA-413A-997A-ED6E8D0F0946}" dt="2025-08-23T09:47:29.664" v="4" actId="47"/>
-        <pc:sldMkLst>
-          <pc:docMk/>
-          <pc:sldMk cId="171635713" sldId="559"/>
-        </pc:sldMkLst>
-      </pc:sldChg>
-      <pc:sldChg chg="del">
-        <pc:chgData name="JORGE GALLUD CANO" userId="aa07a950-3061-465d-9845-1f16ea714d1e" providerId="ADAL" clId="{1CFD8AD4-65FA-413A-997A-ED6E8D0F0946}" dt="2025-08-23T09:47:34.243" v="5" actId="47"/>
-        <pc:sldMkLst>
-          <pc:docMk/>
-          <pc:sldMk cId="2549226878" sldId="560"/>
-        </pc:sldMkLst>
-      </pc:sldChg>
-      <pc:sldChg chg="del">
-        <pc:chgData name="JORGE GALLUD CANO" userId="aa07a950-3061-465d-9845-1f16ea714d1e" providerId="ADAL" clId="{1CFD8AD4-65FA-413A-997A-ED6E8D0F0946}" dt="2025-08-23T09:47:34.243" v="5" actId="47"/>
-        <pc:sldMkLst>
-          <pc:docMk/>
-          <pc:sldMk cId="0" sldId="561"/>
-        </pc:sldMkLst>
-      </pc:sldChg>
-      <pc:sldChg chg="del">
-        <pc:chgData name="JORGE GALLUD CANO" userId="aa07a950-3061-465d-9845-1f16ea714d1e" providerId="ADAL" clId="{1CFD8AD4-65FA-413A-997A-ED6E8D0F0946}" dt="2025-08-23T09:47:34.243" v="5" actId="47"/>
-        <pc:sldMkLst>
-          <pc:docMk/>
-          <pc:sldMk cId="4222404445" sldId="562"/>
-        </pc:sldMkLst>
-      </pc:sldChg>
-      <pc:sldChg chg="del">
-        <pc:chgData name="JORGE GALLUD CANO" userId="aa07a950-3061-465d-9845-1f16ea714d1e" providerId="ADAL" clId="{1CFD8AD4-65FA-413A-997A-ED6E8D0F0946}" dt="2025-08-23T09:47:34.243" v="5" actId="47"/>
-        <pc:sldMkLst>
-          <pc:docMk/>
-          <pc:sldMk cId="386519322" sldId="563"/>
-        </pc:sldMkLst>
-      </pc:sldChg>
-      <pc:sldChg chg="del">
-        <pc:chgData name="JORGE GALLUD CANO" userId="aa07a950-3061-465d-9845-1f16ea714d1e" providerId="ADAL" clId="{1CFD8AD4-65FA-413A-997A-ED6E8D0F0946}" dt="2025-08-23T09:47:34.243" v="5" actId="47"/>
-        <pc:sldMkLst>
-          <pc:docMk/>
-          <pc:sldMk cId="1967072604" sldId="564"/>
-        </pc:sldMkLst>
-      </pc:sldChg>
-      <pc:sldChg chg="del">
-        <pc:chgData name="JORGE GALLUD CANO" userId="aa07a950-3061-465d-9845-1f16ea714d1e" providerId="ADAL" clId="{1CFD8AD4-65FA-413A-997A-ED6E8D0F0946}" dt="2025-08-23T09:47:34.243" v="5" actId="47"/>
-        <pc:sldMkLst>
-          <pc:docMk/>
-          <pc:sldMk cId="3947039945" sldId="565"/>
-        </pc:sldMkLst>
+            <pc:sldMk cId="3622248180" sldId="531"/>
+            <ac:graphicFrameMk id="6" creationId="{003FE4E7-2DE0-8CD0-AD00-A2DFF3A6C228}"/>
+          </ac:graphicFrameMkLst>
+        </pc:graphicFrameChg>
       </pc:sldChg>
     </pc:docChg>
   </pc:docChgLst>
@@ -1158,7 +271,7 @@
           <a:p>
             <a:fld id="{9356850D-52B1-405F-8CD7-E0365C566C9E}" type="datetimeFigureOut">
               <a:rPr lang="es-ES" smtClean="0"/>
-              <a:t>27/10/2025</a:t>
+              <a:t>11/09/2026</a:t>
             </a:fld>
             <a:endParaRPr lang="es-ES"/>
           </a:p>
@@ -1324,7 +437,7 @@
           <a:p>
             <a:fld id="{EA1C35A5-6E39-4CDE-A04F-1B1EEA008340}" type="datetimeFigureOut">
               <a:rPr lang="es-ES" smtClean="0"/>
-              <a:t>27/10/2025</a:t>
+              <a:t>11/09/2026</a:t>
             </a:fld>
             <a:endParaRPr lang="es-ES"/>
           </a:p>
@@ -9857,7 +8970,7 @@
               </a:lnSpc>
             </a:pPr>
             <a:r>
-              <a:rPr lang="en-US" sz="1800"/>
+              <a:rPr lang="en-US" sz="1800" dirty="0"/>
               <a:t>Balance sheet and notes if 2 circumstances occur in 2 years:</a:t>
             </a:r>
           </a:p>
@@ -9868,16 +8981,8 @@
               </a:lnSpc>
             </a:pPr>
             <a:r>
-              <a:rPr lang="en-US" sz="1800"/>
-              <a:t>Total </a:t>
-            </a:r>
-            <a:r>
-              <a:rPr lang="en-US" sz="1800" err="1"/>
-              <a:t>assets ≤ </a:t>
-            </a:r>
-            <a:r>
-              <a:rPr lang="en-US" sz="1800"/>
-              <a:t>4.000.000 €.</a:t>
+              <a:rPr lang="en-US" sz="1800" dirty="0"/>
+              <a:t>Total assets ≤ 4.000.000 €.</a:t>
             </a:r>
           </a:p>
           <a:p>
@@ -9887,7 +8992,7 @@
               </a:lnSpc>
             </a:pPr>
             <a:r>
-              <a:rPr lang="en-US" sz="1800"/>
+              <a:rPr lang="en-US" sz="1800" dirty="0"/>
               <a:t>Sales ≤ 8.000.000 €.</a:t>
             </a:r>
           </a:p>
@@ -9898,39 +9003,39 @@
               </a:lnSpc>
             </a:pPr>
             <a:r>
-              <a:rPr lang="es-ES" err="1"/>
+              <a:rPr lang="es-ES" dirty="0" err="1"/>
               <a:t>Average</a:t>
             </a:r>
             <a:r>
-              <a:rPr lang="es-ES"/>
+              <a:rPr lang="es-ES" dirty="0"/>
               <a:t> </a:t>
             </a:r>
             <a:r>
-              <a:rPr lang="es-ES" err="1"/>
+              <a:rPr lang="es-ES" dirty="0" err="1"/>
               <a:t>number</a:t>
             </a:r>
             <a:r>
-              <a:rPr lang="es-ES"/>
+              <a:rPr lang="es-ES" dirty="0"/>
               <a:t> </a:t>
             </a:r>
             <a:r>
-              <a:rPr lang="es-ES" err="1"/>
+              <a:rPr lang="es-ES" dirty="0" err="1"/>
               <a:t>of</a:t>
             </a:r>
             <a:r>
-              <a:rPr lang="es-ES"/>
+              <a:rPr lang="es-ES" dirty="0"/>
               <a:t> </a:t>
             </a:r>
             <a:r>
-              <a:rPr lang="es-ES" err="1"/>
+              <a:rPr lang="es-ES" dirty="0" err="1"/>
               <a:t>employees</a:t>
             </a:r>
             <a:r>
-              <a:rPr lang="es-ES"/>
+              <a:rPr lang="es-ES" dirty="0"/>
               <a:t> </a:t>
             </a:r>
             <a:r>
-              <a:rPr lang="en-US" sz="1800"/>
+              <a:rPr lang="en-US" sz="1800" dirty="0"/>
               <a:t>≤ 50</a:t>
             </a:r>
           </a:p>
@@ -9941,7 +9046,7 @@
               </a:lnSpc>
             </a:pPr>
             <a:r>
-              <a:rPr lang="en-US" sz="1800"/>
+              <a:rPr lang="en-US" sz="1800" dirty="0"/>
               <a:t>It implies that SCE and CFS are not mandatory.</a:t>
             </a:r>
           </a:p>
@@ -9952,7 +9057,7 @@
               </a:lnSpc>
             </a:pPr>
             <a:r>
-              <a:rPr lang="en-US" sz="1800"/>
+              <a:rPr lang="en-US" sz="1800" dirty="0"/>
               <a:t>Only abbreviated P&amp;L if 2 circumstances occur in 2 years:</a:t>
             </a:r>
           </a:p>
@@ -9963,16 +9068,8 @@
               </a:lnSpc>
             </a:pPr>
             <a:r>
-              <a:rPr lang="en-US" sz="1800"/>
-              <a:t>Total </a:t>
-            </a:r>
-            <a:r>
-              <a:rPr lang="en-US" sz="1800" err="1"/>
-              <a:t>assets ≤ </a:t>
-            </a:r>
-            <a:r>
-              <a:rPr lang="en-US" sz="1800"/>
-              <a:t>11.400.000 €.</a:t>
+              <a:rPr lang="en-US" sz="1800" dirty="0"/>
+              <a:t>Total assets ≤ 11.400.000 €.</a:t>
             </a:r>
           </a:p>
           <a:p>
@@ -9982,11 +9079,11 @@
               </a:lnSpc>
             </a:pPr>
             <a:r>
-              <a:rPr lang="en-US"/>
+              <a:rPr lang="en-US" dirty="0"/>
               <a:t>Sales</a:t>
             </a:r>
             <a:r>
-              <a:rPr lang="en-US" sz="1800"/>
+              <a:rPr lang="en-US" sz="1800" dirty="0"/>
               <a:t> ≤ 22.800.000 €.</a:t>
             </a:r>
           </a:p>
@@ -9997,39 +9094,39 @@
               </a:lnSpc>
             </a:pPr>
             <a:r>
-              <a:rPr lang="es-ES" err="1"/>
+              <a:rPr lang="es-ES" dirty="0" err="1"/>
               <a:t>Average</a:t>
             </a:r>
             <a:r>
-              <a:rPr lang="es-ES"/>
+              <a:rPr lang="es-ES" dirty="0"/>
               <a:t> </a:t>
             </a:r>
             <a:r>
-              <a:rPr lang="es-ES" err="1"/>
+              <a:rPr lang="es-ES" dirty="0" err="1"/>
               <a:t>number</a:t>
             </a:r>
             <a:r>
-              <a:rPr lang="es-ES"/>
+              <a:rPr lang="es-ES" dirty="0"/>
               <a:t> </a:t>
             </a:r>
             <a:r>
-              <a:rPr lang="es-ES" err="1"/>
+              <a:rPr lang="es-ES" dirty="0" err="1"/>
               <a:t>of</a:t>
             </a:r>
             <a:r>
-              <a:rPr lang="es-ES"/>
+              <a:rPr lang="es-ES" dirty="0"/>
               <a:t> </a:t>
             </a:r>
             <a:r>
-              <a:rPr lang="es-ES" err="1"/>
+              <a:rPr lang="es-ES" dirty="0" err="1"/>
               <a:t>employees</a:t>
             </a:r>
             <a:r>
-              <a:rPr lang="es-ES"/>
+              <a:rPr lang="es-ES" dirty="0"/>
               <a:t> </a:t>
             </a:r>
             <a:r>
-              <a:rPr lang="en-US" sz="1800"/>
+              <a:rPr lang="en-US" sz="1800" dirty="0"/>
               <a:t>≤ 250</a:t>
             </a:r>
           </a:p>
@@ -10109,7 +9206,7 @@
             <p:ph idx="1"/>
             <p:extLst>
               <p:ext uri="{D42A27DB-BD31-4B8C-83A1-F6EECF244321}">
-                <p14:modId xmlns:p14="http://schemas.microsoft.com/office/powerpoint/2010/main" val="9289670"/>
+                <p14:modId xmlns:p14="http://schemas.microsoft.com/office/powerpoint/2010/main" val="4209378043"/>
               </p:ext>
             </p:extLst>
           </p:nvPr>
@@ -12699,7 +11796,7 @@
                         </a:tabLst>
                       </a:pPr>
                       <a:r>
-                        <a:rPr kumimoji="0" lang="es-ES_tradnl" sz="1800" b="0" i="0" u="none" strike="noStrike" cap="none" normalizeH="0" baseline="0">
+                        <a:rPr kumimoji="0" lang="es-ES_tradnl" sz="1800" b="0" i="0" u="none" strike="noStrike" cap="none" normalizeH="0" baseline="0" dirty="0">
                           <a:ln>
                             <a:noFill/>
                           </a:ln>
@@ -12711,7 +11808,37 @@
                           <a:ea typeface="Lucida Sans Unicode" pitchFamily="34" charset="0"/>
                           <a:cs typeface="Lucida Sans Unicode" pitchFamily="34" charset="0"/>
                         </a:rPr>
-                        <a:t>Audit report</a:t>
+                        <a:t>Audit </a:t>
+                      </a:r>
+                      <a:r>
+                        <a:rPr kumimoji="0" lang="es-ES_tradnl" sz="1800" b="0" i="0" u="none" strike="noStrike" cap="none" normalizeH="0" baseline="0" dirty="0" err="1">
+                          <a:ln>
+                            <a:noFill/>
+                          </a:ln>
+                          <a:solidFill>
+                            <a:schemeClr val="tx1"/>
+                          </a:solidFill>
+                          <a:effectLst/>
+                          <a:latin typeface="+mn-lt"/>
+                          <a:ea typeface="Lucida Sans Unicode" pitchFamily="34" charset="0"/>
+                          <a:cs typeface="Lucida Sans Unicode" pitchFamily="34" charset="0"/>
+                        </a:rPr>
+                        <a:t>report</a:t>
+                      </a:r>
+                      <a:r>
+                        <a:rPr kumimoji="0" lang="es-ES_tradnl" sz="1800" b="0" i="0" u="none" strike="noStrike" cap="none" normalizeH="0" baseline="0" dirty="0">
+                          <a:ln>
+                            <a:noFill/>
+                          </a:ln>
+                          <a:solidFill>
+                            <a:schemeClr val="tx1"/>
+                          </a:solidFill>
+                          <a:effectLst/>
+                          <a:latin typeface="+mn-lt"/>
+                          <a:ea typeface="Lucida Sans Unicode" pitchFamily="34" charset="0"/>
+                          <a:cs typeface="Lucida Sans Unicode" pitchFamily="34" charset="0"/>
+                        </a:rPr>
+                        <a:t>*</a:t>
                       </a:r>
                     </a:p>
                   </a:txBody>
@@ -12954,7 +12081,7 @@
                         </a:tabLst>
                       </a:pPr>
                       <a:r>
-                        <a:rPr kumimoji="0" lang="es-ES_tradnl" sz="1800" b="0" i="0" u="none" strike="noStrike" cap="none" normalizeH="0" baseline="0">
+                        <a:rPr kumimoji="0" lang="es-ES_tradnl" sz="1800" b="0" i="0" u="none" strike="noStrike" cap="none" normalizeH="0" baseline="0" dirty="0">
                           <a:ln>
                             <a:noFill/>
                           </a:ln>
@@ -13022,6 +12149,42 @@
           </a:graphicData>
         </a:graphic>
       </p:graphicFrame>
+      <p:sp>
+        <p:nvSpPr>
+          <p:cNvPr id="4" name="CuadroTexto 3">
+            <a:extLst>
+              <a:ext uri="{FF2B5EF4-FFF2-40B4-BE49-F238E27FC236}">
+                <a16:creationId xmlns:a16="http://schemas.microsoft.com/office/drawing/2014/main" id="{05D68C07-B7C5-F0F9-76DB-F255B5CBE83F}"/>
+              </a:ext>
+            </a:extLst>
+          </p:cNvPr>
+          <p:cNvSpPr txBox="1"/>
+          <p:nvPr/>
+        </p:nvSpPr>
+        <p:spPr>
+          <a:xfrm>
+            <a:off x="628649" y="5444609"/>
+            <a:ext cx="7846789" cy="338554"/>
+          </a:xfrm>
+          <a:prstGeom prst="rect">
+            <a:avLst/>
+          </a:prstGeom>
+          <a:noFill/>
+        </p:spPr>
+        <p:txBody>
+          <a:bodyPr wrap="square">
+            <a:spAutoFit/>
+          </a:bodyPr>
+          <a:lstStyle/>
+          <a:p>
+            <a:r>
+              <a:rPr lang="en-US" sz="1600" dirty="0"/>
+              <a:t>*The obligation to audit has its own thresholds, which are lower.</a:t>
+            </a:r>
+            <a:endParaRPr lang="es-ES" sz="1600" dirty="0"/>
+          </a:p>
+        </p:txBody>
+      </p:sp>
     </p:spTree>
     <p:extLst>
       <p:ext uri="{BB962C8B-B14F-4D97-AF65-F5344CB8AC3E}">

</xml_diff>